<commit_message>
report(pptx): slide 5 — add scorecard + 14-module coverage checklist
Two-column layout: condensed bullets (left) + stat tiles (14/14, +1, 15, 0)
and a DVWA 14-module coverage checklist with the +1 bonus highlighted (right).

Co-Authored-By: Claude Opus 4.8 <noreply@anthropic.com>
Claude-Session: https://claude.ai/code/session_011vgqo4WsaN8pow4b5t3FcQ
</commit_message>
<xml_diff>
--- a/ARTEX_DVWA_요약보고서.pptx
+++ b/ARTEX_DVWA_요약보고서.pptx
@@ -4593,7 +4593,7 @@
         <p:spPr>
           <a:xfrm>
             <a:off x="445770" y="850320"/>
-            <a:ext cx="8915400" cy="5170968"/>
+            <a:ext cx="4520000" cy="5170968"/>
           </a:xfrm>
           <a:prstGeom prst="rect">
             <a:avLst/>
@@ -4761,7 +4761,7 @@
           <a:p>
             <a:pPr/>
             <a:r>
-              <a:rPr lang="ko-KR" altLang="en-US" sz="1500" b="0" dirty="0">
+              <a:rPr lang="ko-KR" altLang="en-US" sz="1400" b="1" dirty="0">
                 <a:solidFill>
                   <a:srgbClr val="000000"/>
                 </a:solidFill>
@@ -4775,18 +4775,18 @@
           <a:p>
             <a:pPr lvl="1"/>
             <a:r>
-              <a:rPr lang="ko-KR" altLang="en-US" sz="1300" b="0" dirty="0">
-                <a:solidFill>
-                  <a:srgbClr val="000000"/>
-                </a:solidFill>
-                <a:latin typeface="맑은 고딕"/>
-                <a:ea typeface="맑은 고딕"/>
-                <a:cs typeface="맑은 고딕"/>
-              </a:rPr>
-              <a:t xml:space="preserve">DVWA가 보유한 알려진 취약점 표면을 빠짐없이 탐지 → </a:t>
-            </a:r>
-            <a:r>
-              <a:rPr lang="ko-KR" altLang="en-US" sz="1300" b="1" dirty="0">
+              <a:rPr lang="ko-KR" altLang="en-US" sz="1250" b="0" dirty="0">
+                <a:solidFill>
+                  <a:srgbClr val="000000"/>
+                </a:solidFill>
+                <a:latin typeface="맑은 고딕"/>
+                <a:ea typeface="맑은 고딕"/>
+                <a:cs typeface="맑은 고딕"/>
+              </a:rPr>
+              <a:t xml:space="preserve">DVWA 알려진 취약점 표면 전체 탐지 → </a:t>
+            </a:r>
+            <a:r>
+              <a:rPr lang="ko-KR" altLang="en-US" sz="1250" b="1" dirty="0">
                 <a:solidFill>
                   <a:srgbClr val="1F497D"/>
                 </a:solidFill>
@@ -4794,74 +4794,105 @@
                 <a:ea typeface="맑은 고딕"/>
                 <a:cs typeface="맑은 고딕"/>
               </a:rPr>
-              <a:t xml:space="preserve">커버리지 14/14 (100%), 누락 0건</a:t>
+              <a:t xml:space="preserve">커버리지 14/14, 누락 0</a:t>
             </a:r>
           </a:p>
           <a:p>
             <a:pPr lvl="1"/>
             <a:r>
-              <a:rPr lang="ko-KR" altLang="en-US" sz="1300" b="0" dirty="0">
-                <a:solidFill>
-                  <a:srgbClr val="000000"/>
-                </a:solidFill>
-                <a:latin typeface="맑은 고딕"/>
-                <a:ea typeface="맑은 고딕"/>
-                <a:cs typeface="맑은 고딕"/>
-              </a:rPr>
-              <a:t xml:space="preserve">의도된 경로가 막힌 항목도 대체 각도로 접근해 결함을 확인(</a:t>
-            </a:r>
-            <a:r>
-              <a:rPr lang="ko-KR" altLang="en-US" sz="1300" b="1" dirty="0">
-                <a:solidFill>
-                  <a:srgbClr val="000000"/>
-                </a:solidFill>
-                <a:latin typeface="맑은 고딕"/>
-                <a:ea typeface="맑은 고딕"/>
-                <a:cs typeface="맑은 고딕"/>
-              </a:rPr>
-              <a:t xml:space="preserve">단순 매칭이 아님</a:t>
-            </a:r>
-            <a:r>
-              <a:rPr lang="ko-KR" altLang="en-US" sz="1300" b="0" dirty="0">
-                <a:solidFill>
-                  <a:srgbClr val="000000"/>
-                </a:solidFill>
-                <a:latin typeface="맑은 고딕"/>
-                <a:ea typeface="맑은 고딕"/>
-                <a:cs typeface="맑은 고딕"/>
-              </a:rPr>
-              <a:t xml:space="preserve">)</a:t>
+              <a:rPr lang="ko-KR" altLang="en-US" sz="1250" b="0" dirty="0">
+                <a:solidFill>
+                  <a:srgbClr val="000000"/>
+                </a:solidFill>
+                <a:latin typeface="맑은 고딕"/>
+                <a:ea typeface="맑은 고딕"/>
+                <a:cs typeface="맑은 고딕"/>
+              </a:rPr>
+              <a:t xml:space="preserve">막힌 경로도 대체 각도로 결함 확인(단순 매칭 아님)</a:t>
             </a:r>
           </a:p>
           <a:p>
             <a:pPr/>
             <a:r>
-              <a:rPr lang="ko-KR" altLang="en-US" sz="1500" b="0" dirty="0">
-                <a:solidFill>
-                  <a:srgbClr val="000000"/>
-                </a:solidFill>
-                <a:latin typeface="맑은 고딕"/>
-                <a:ea typeface="맑은 고딕"/>
-                <a:cs typeface="맑은 고딕"/>
-              </a:rPr>
-              <a:t xml:space="preserve">확장성 — 정답지 밖 1건 추가 발견</a:t>
+              <a:rPr lang="ko-KR" altLang="en-US" sz="1400" b="1" dirty="0">
+                <a:solidFill>
+                  <a:srgbClr val="000000"/>
+                </a:solidFill>
+                <a:latin typeface="맑은 고딕"/>
+                <a:ea typeface="맑은 고딕"/>
+                <a:cs typeface="맑은 고딕"/>
+              </a:rPr>
+              <a:t xml:space="preserve">확장성 — 정답지 밖 1건 추가</a:t>
             </a:r>
           </a:p>
           <a:p>
             <a:pPr lvl="1"/>
             <a:r>
-              <a:rPr lang="ko-KR" altLang="en-US" sz="1300" b="0" dirty="0">
-                <a:solidFill>
-                  <a:srgbClr val="000000"/>
-                </a:solidFill>
-                <a:latin typeface="맑은 고딕"/>
-                <a:ea typeface="맑은 고딕"/>
-                <a:cs typeface="맑은 고딕"/>
-              </a:rPr>
-              <a:t xml:space="preserve">모듈에 정의되지 않은 </a:t>
-            </a:r>
-            <a:r>
-              <a:rPr lang="ko-KR" altLang="en-US" sz="1300" b="1" dirty="0">
+              <a:rPr lang="ko-KR" altLang="en-US" sz="1250" b="0" dirty="0">
+                <a:solidFill>
+                  <a:srgbClr val="000000"/>
+                </a:solidFill>
+                <a:latin typeface="맑은 고딕"/>
+                <a:ea typeface="맑은 고딕"/>
+                <a:cs typeface="맑은 고딕"/>
+              </a:rPr>
+              <a:t xml:space="preserve">모듈에 없는 </a:t>
+            </a:r>
+            <a:r>
+              <a:rPr lang="ko-KR" altLang="en-US" sz="1250" b="1" dirty="0">
+                <a:solidFill>
+                  <a:srgbClr val="C0504D"/>
+                </a:solidFill>
+                <a:latin typeface="맑은 고딕"/>
+                <a:ea typeface="맑은 고딕"/>
+                <a:cs typeface="맑은 고딕"/>
+              </a:rPr>
+              <a:t xml:space="preserve">서버 설정 결함 1건 자율 포착</a:t>
+            </a:r>
+          </a:p>
+          <a:p>
+            <a:pPr/>
+            <a:r>
+              <a:rPr lang="ko-KR" altLang="en-US" sz="1400" b="1" dirty="0">
+                <a:solidFill>
+                  <a:srgbClr val="000000"/>
+                </a:solidFill>
+                <a:latin typeface="맑은 고딕"/>
+                <a:ea typeface="맑은 고딕"/>
+                <a:cs typeface="맑은 고딕"/>
+              </a:rPr>
+              <a:t xml:space="preserve">자율성 — 사람 개입 없는 완주</a:t>
+            </a:r>
+          </a:p>
+          <a:p>
+            <a:pPr lvl="1"/>
+            <a:r>
+              <a:rPr lang="ko-KR" altLang="en-US" sz="1250" b="0" dirty="0">
+                <a:solidFill>
+                  <a:srgbClr val="000000"/>
+                </a:solidFill>
+                <a:latin typeface="맑은 고딕"/>
+                <a:ea typeface="맑은 고딕"/>
+                <a:cs typeface="맑은 고딕"/>
+              </a:rPr>
+              <a:t xml:space="preserve">단일 지시로 정찰→침투→검증→등록 자동 완료</a:t>
+            </a:r>
+          </a:p>
+          <a:p>
+            <a:pPr lvl="1"/>
+            <a:r>
+              <a:rPr lang="ko-KR" altLang="en-US" sz="1250" b="0" dirty="0">
+                <a:solidFill>
+                  <a:srgbClr val="000000"/>
+                </a:solidFill>
+                <a:latin typeface="맑은 고딕"/>
+                <a:ea typeface="맑은 고딕"/>
+                <a:cs typeface="맑은 고딕"/>
+              </a:rPr>
+              <a:t xml:space="preserve">총 </a:t>
+            </a:r>
+            <a:r>
+              <a:rPr lang="ko-KR" altLang="en-US" sz="1250" b="1" dirty="0">
                 <a:solidFill>
                   <a:srgbClr val="1F497D"/>
                 </a:solidFill>
@@ -4869,77 +4900,86 @@
                 <a:ea typeface="맑은 고딕"/>
                 <a:cs typeface="맑은 고딕"/>
               </a:rPr>
-              <a:t xml:space="preserve">서버 설정 결함 1건을 자율 추가 포착</a:t>
+              <a:t xml:space="preserve">15건 확정 등록</a:t>
+            </a:r>
+            <a:r>
+              <a:rPr lang="ko-KR" altLang="en-US" sz="1250" b="0" dirty="0">
+                <a:solidFill>
+                  <a:srgbClr val="000000"/>
+                </a:solidFill>
+                <a:latin typeface="맑은 고딕"/>
+                <a:ea typeface="맑은 고딕"/>
+                <a:cs typeface="맑은 고딕"/>
+              </a:rPr>
+              <a:t xml:space="preserve">, 라이브 재검증</a:t>
             </a:r>
           </a:p>
           <a:p>
             <a:pPr lvl="1"/>
             <a:r>
-              <a:rPr lang="ko-KR" altLang="en-US" sz="1300" b="0" dirty="0">
-                <a:solidFill>
-                  <a:srgbClr val="000000"/>
-                </a:solidFill>
-                <a:latin typeface="맑은 고딕"/>
-                <a:ea typeface="맑은 고딕"/>
-                <a:cs typeface="맑은 고딕"/>
-              </a:rPr>
-              <a:t xml:space="preserve">스크립트형 스캐너가 놓치기 쉬운 '범위 외 결함'까지 스스로 탐색</a:t>
-            </a:r>
-          </a:p>
-          <a:p>
-            <a:pPr/>
-            <a:r>
-              <a:rPr lang="ko-KR" altLang="en-US" sz="1500" b="0" dirty="0">
-                <a:solidFill>
-                  <a:srgbClr val="000000"/>
-                </a:solidFill>
-                <a:latin typeface="맑은 고딕"/>
-                <a:ea typeface="맑은 고딕"/>
-                <a:cs typeface="맑은 고딕"/>
-              </a:rPr>
-              <a:t xml:space="preserve">자율성 — 사람 개입 없는 완주</a:t>
-            </a:r>
-          </a:p>
-          <a:p>
-            <a:pPr lvl="1"/>
-            <a:r>
-              <a:rPr lang="ko-KR" altLang="en-US" sz="1300" b="0" dirty="0">
-                <a:solidFill>
-                  <a:srgbClr val="000000"/>
-                </a:solidFill>
-                <a:latin typeface="맑은 고딕"/>
-                <a:ea typeface="맑은 고딕"/>
-                <a:cs typeface="맑은 고딕"/>
-              </a:rPr>
-              <a:t xml:space="preserve">단일 지시로 정찰→침투→검증→등록의 </a:t>
-            </a:r>
-            <a:r>
-              <a:rPr lang="ko-KR" altLang="en-US" sz="1300" b="1" dirty="0">
-                <a:solidFill>
-                  <a:srgbClr val="000000"/>
-                </a:solidFill>
-                <a:latin typeface="맑은 고딕"/>
-                <a:ea typeface="맑은 고딕"/>
-                <a:cs typeface="맑은 고딕"/>
-              </a:rPr>
-              <a:t xml:space="preserve">전 파이프라인을 자동 완료</a:t>
-            </a:r>
-          </a:p>
-          <a:p>
-            <a:pPr lvl="1"/>
-            <a:r>
-              <a:rPr lang="ko-KR" altLang="en-US" sz="1300" b="0" dirty="0">
-                <a:solidFill>
-                  <a:srgbClr val="000000"/>
-                </a:solidFill>
-                <a:latin typeface="맑은 고딕"/>
-                <a:ea typeface="맑은 고딕"/>
-                <a:cs typeface="맑은 고딕"/>
-              </a:rPr>
-              <a:t xml:space="preserve">총 </a:t>
-            </a:r>
-            <a:r>
-              <a:rPr lang="ko-KR" altLang="en-US" sz="1300" b="1" dirty="0">
+              <a:rPr lang="ko-KR" altLang="en-US" sz="1250" b="0" dirty="0">
+                <a:solidFill>
+                  <a:srgbClr val="000000"/>
+                </a:solidFill>
+                <a:latin typeface="맑은 고딕"/>
+                <a:ea typeface="맑은 고딕"/>
+                <a:cs typeface="맑은 고딕"/>
+              </a:rPr>
+              <a:t xml:space="preserve">요지: 핵심은 '무엇이 취약한가'가 아니라 </a:t>
+            </a:r>
+            <a:r>
+              <a:rPr lang="ko-KR" altLang="en-US" sz="1250" b="1" dirty="0">
+                <a:solidFill>
+                  <a:srgbClr val="000000"/>
+                </a:solidFill>
+                <a:latin typeface="맑은 고딕"/>
+                <a:ea typeface="맑은 고딕"/>
+                <a:cs typeface="맑은 고딕"/>
+              </a:rPr>
+              <a:t xml:space="preserve">전부 + 하나 더 찾은 완전성</a:t>
+            </a:r>
+          </a:p>
+        </p:txBody>
+      </p:sp>
+      <p:sp>
+        <p:nvSpPr>
+          <p:cNvPr id="201" name="viz201"/>
+          <p:cNvSpPr txBox="1"/>
+          <p:nvPr/>
+        </p:nvSpPr>
+        <p:spPr>
+          <a:xfrm>
+            <a:off x="5150000" y="850320"/>
+            <a:ext cx="2045585" cy="860000"/>
+          </a:xfrm>
+          <a:prstGeom prst="roundRect">
+            <a:avLst>
+              <a:gd name="adj" fmla="val 8000"/>
+            </a:avLst>
+          </a:prstGeom>
+          <a:solidFill>
+            <a:srgbClr val="F2F4F8"/>
+          </a:solidFill>
+          <a:ln w="9525">
+            <a:solidFill>
+              <a:srgbClr val="D4DAE6"/>
+            </a:solidFill>
+          </a:ln>
+        </p:spPr>
+        <p:txBody>
+          <a:bodyPr wrap="square" anchor="ctr" lIns="45720" tIns="18288" rIns="45720" bIns="18288">
+            <a:normAutofit/>
+          </a:bodyPr>
+          <a:lstStyle/>
+          <a:p>
+            <a:pPr algn="ctr">
+              <a:buNone/>
+              <a:spcAft>
+                <a:spcPts val="200"/>
+              </a:spcAft>
+            </a:pPr>
+            <a:r>
+              <a:rPr lang="ko-KR" altLang="en-US" sz="2800" b="1" dirty="0">
                 <a:solidFill>
                   <a:srgbClr val="1F497D"/>
                 </a:solidFill>
@@ -4947,43 +4987,797 @@
                 <a:ea typeface="맑은 고딕"/>
                 <a:cs typeface="맑은 고딕"/>
               </a:rPr>
-              <a:t xml:space="preserve">15건 확정 등록</a:t>
-            </a:r>
-            <a:r>
-              <a:rPr lang="ko-KR" altLang="en-US" sz="1300" b="0" dirty="0">
-                <a:solidFill>
-                  <a:srgbClr val="000000"/>
-                </a:solidFill>
-                <a:latin typeface="맑은 고딕"/>
-                <a:ea typeface="맑은 고딕"/>
-                <a:cs typeface="맑은 고딕"/>
-              </a:rPr>
-              <a:t xml:space="preserve">(전 과정 자율), 라이브 재검증으로 유효성 재확인</a:t>
-            </a:r>
-          </a:p>
-          <a:p>
-            <a:pPr lvl="1"/>
-            <a:r>
-              <a:rPr lang="ko-KR" altLang="en-US" sz="1300" b="0" dirty="0">
-                <a:solidFill>
-                  <a:srgbClr val="000000"/>
-                </a:solidFill>
-                <a:latin typeface="맑은 고딕"/>
-                <a:ea typeface="맑은 고딕"/>
-                <a:cs typeface="맑은 고딕"/>
-              </a:rPr>
-              <a:t xml:space="preserve">요지: 핵심은 '무엇이 취약한가'가 아니라, </a:t>
-            </a:r>
-            <a:r>
-              <a:rPr lang="ko-KR" altLang="en-US" sz="1300" b="1" dirty="0">
-                <a:solidFill>
-                  <a:srgbClr val="000000"/>
-                </a:solidFill>
-                <a:latin typeface="맑은 고딕"/>
-                <a:ea typeface="맑은 고딕"/>
-                <a:cs typeface="맑은 고딕"/>
-              </a:rPr>
-              <a:t xml:space="preserve">알려진 것을 전부 + 하나 더 찾아낸 완전성</a:t>
+              <a:t xml:space="preserve">14/14</a:t>
+            </a:r>
+          </a:p>
+          <a:p>
+            <a:pPr algn="ctr">
+              <a:buNone/>
+            </a:pPr>
+            <a:r>
+              <a:rPr lang="ko-KR" altLang="en-US" sz="1050" b="0" dirty="0">
+                <a:solidFill>
+                  <a:srgbClr val="595959"/>
+                </a:solidFill>
+                <a:latin typeface="맑은 고딕"/>
+                <a:ea typeface="맑은 고딕"/>
+                <a:cs typeface="맑은 고딕"/>
+              </a:rPr>
+              <a:t xml:space="preserve">모듈 커버리지 (100%)</a:t>
+            </a:r>
+          </a:p>
+        </p:txBody>
+      </p:sp>
+      <p:sp>
+        <p:nvSpPr>
+          <p:cNvPr id="202" name="viz202"/>
+          <p:cNvSpPr txBox="1"/>
+          <p:nvPr/>
+        </p:nvSpPr>
+        <p:spPr>
+          <a:xfrm>
+            <a:off x="7315585" y="850320"/>
+            <a:ext cx="2045585" cy="860000"/>
+          </a:xfrm>
+          <a:prstGeom prst="roundRect">
+            <a:avLst>
+              <a:gd name="adj" fmla="val 8000"/>
+            </a:avLst>
+          </a:prstGeom>
+          <a:solidFill>
+            <a:srgbClr val="F2F4F8"/>
+          </a:solidFill>
+          <a:ln w="9525">
+            <a:solidFill>
+              <a:srgbClr val="D4DAE6"/>
+            </a:solidFill>
+          </a:ln>
+        </p:spPr>
+        <p:txBody>
+          <a:bodyPr wrap="square" anchor="ctr" lIns="45720" tIns="18288" rIns="45720" bIns="18288">
+            <a:normAutofit/>
+          </a:bodyPr>
+          <a:lstStyle/>
+          <a:p>
+            <a:pPr algn="ctr">
+              <a:buNone/>
+              <a:spcAft>
+                <a:spcPts val="200"/>
+              </a:spcAft>
+            </a:pPr>
+            <a:r>
+              <a:rPr lang="ko-KR" altLang="en-US" sz="2800" b="1" dirty="0">
+                <a:solidFill>
+                  <a:srgbClr val="C0504D"/>
+                </a:solidFill>
+                <a:latin typeface="맑은 고딕"/>
+                <a:ea typeface="맑은 고딕"/>
+                <a:cs typeface="맑은 고딕"/>
+              </a:rPr>
+              <a:t xml:space="preserve">+1</a:t>
+            </a:r>
+          </a:p>
+          <a:p>
+            <a:pPr algn="ctr">
+              <a:buNone/>
+            </a:pPr>
+            <a:r>
+              <a:rPr lang="ko-KR" altLang="en-US" sz="1050" b="0" dirty="0">
+                <a:solidFill>
+                  <a:srgbClr val="595959"/>
+                </a:solidFill>
+                <a:latin typeface="맑은 고딕"/>
+                <a:ea typeface="맑은 고딕"/>
+                <a:cs typeface="맑은 고딕"/>
+              </a:rPr>
+              <a:t xml:space="preserve">정답지 밖 추가 발견</a:t>
+            </a:r>
+          </a:p>
+        </p:txBody>
+      </p:sp>
+      <p:sp>
+        <p:nvSpPr>
+          <p:cNvPr id="203" name="viz203"/>
+          <p:cNvSpPr txBox="1"/>
+          <p:nvPr/>
+        </p:nvSpPr>
+        <p:spPr>
+          <a:xfrm>
+            <a:off x="5150000" y="1830320"/>
+            <a:ext cx="2045585" cy="860000"/>
+          </a:xfrm>
+          <a:prstGeom prst="roundRect">
+            <a:avLst>
+              <a:gd name="adj" fmla="val 8000"/>
+            </a:avLst>
+          </a:prstGeom>
+          <a:solidFill>
+            <a:srgbClr val="F2F4F8"/>
+          </a:solidFill>
+          <a:ln w="9525">
+            <a:solidFill>
+              <a:srgbClr val="D4DAE6"/>
+            </a:solidFill>
+          </a:ln>
+        </p:spPr>
+        <p:txBody>
+          <a:bodyPr wrap="square" anchor="ctr" lIns="45720" tIns="18288" rIns="45720" bIns="18288">
+            <a:normAutofit/>
+          </a:bodyPr>
+          <a:lstStyle/>
+          <a:p>
+            <a:pPr algn="ctr">
+              <a:buNone/>
+              <a:spcAft>
+                <a:spcPts val="200"/>
+              </a:spcAft>
+            </a:pPr>
+            <a:r>
+              <a:rPr lang="ko-KR" altLang="en-US" sz="2800" b="1" dirty="0">
+                <a:solidFill>
+                  <a:srgbClr val="1F497D"/>
+                </a:solidFill>
+                <a:latin typeface="맑은 고딕"/>
+                <a:ea typeface="맑은 고딕"/>
+                <a:cs typeface="맑은 고딕"/>
+              </a:rPr>
+              <a:t xml:space="preserve">15</a:t>
+            </a:r>
+          </a:p>
+          <a:p>
+            <a:pPr algn="ctr">
+              <a:buNone/>
+            </a:pPr>
+            <a:r>
+              <a:rPr lang="ko-KR" altLang="en-US" sz="1050" b="0" dirty="0">
+                <a:solidFill>
+                  <a:srgbClr val="595959"/>
+                </a:solidFill>
+                <a:latin typeface="맑은 고딕"/>
+                <a:ea typeface="맑은 고딕"/>
+                <a:cs typeface="맑은 고딕"/>
+              </a:rPr>
+              <a:t xml:space="preserve">총 확정 등록</a:t>
+            </a:r>
+          </a:p>
+        </p:txBody>
+      </p:sp>
+      <p:sp>
+        <p:nvSpPr>
+          <p:cNvPr id="204" name="viz204"/>
+          <p:cNvSpPr txBox="1"/>
+          <p:nvPr/>
+        </p:nvSpPr>
+        <p:spPr>
+          <a:xfrm>
+            <a:off x="7315585" y="1830320"/>
+            <a:ext cx="2045585" cy="860000"/>
+          </a:xfrm>
+          <a:prstGeom prst="roundRect">
+            <a:avLst>
+              <a:gd name="adj" fmla="val 8000"/>
+            </a:avLst>
+          </a:prstGeom>
+          <a:solidFill>
+            <a:srgbClr val="F2F4F8"/>
+          </a:solidFill>
+          <a:ln w="9525">
+            <a:solidFill>
+              <a:srgbClr val="D4DAE6"/>
+            </a:solidFill>
+          </a:ln>
+        </p:spPr>
+        <p:txBody>
+          <a:bodyPr wrap="square" anchor="ctr" lIns="45720" tIns="18288" rIns="45720" bIns="18288">
+            <a:normAutofit/>
+          </a:bodyPr>
+          <a:lstStyle/>
+          <a:p>
+            <a:pPr algn="ctr">
+              <a:buNone/>
+              <a:spcAft>
+                <a:spcPts val="200"/>
+              </a:spcAft>
+            </a:pPr>
+            <a:r>
+              <a:rPr lang="ko-KR" altLang="en-US" sz="2800" b="1" dirty="0">
+                <a:solidFill>
+                  <a:srgbClr val="4F7A28"/>
+                </a:solidFill>
+                <a:latin typeface="맑은 고딕"/>
+                <a:ea typeface="맑은 고딕"/>
+                <a:cs typeface="맑은 고딕"/>
+              </a:rPr>
+              <a:t xml:space="preserve">0</a:t>
+            </a:r>
+          </a:p>
+          <a:p>
+            <a:pPr algn="ctr">
+              <a:buNone/>
+            </a:pPr>
+            <a:r>
+              <a:rPr lang="ko-KR" altLang="en-US" sz="1050" b="0" dirty="0">
+                <a:solidFill>
+                  <a:srgbClr val="595959"/>
+                </a:solidFill>
+                <a:latin typeface="맑은 고딕"/>
+                <a:ea typeface="맑은 고딕"/>
+                <a:cs typeface="맑은 고딕"/>
+              </a:rPr>
+              <a:t xml:space="preserve">누락</a:t>
+            </a:r>
+          </a:p>
+        </p:txBody>
+      </p:sp>
+      <p:sp>
+        <p:nvSpPr>
+          <p:cNvPr id="205" name="viz205"/>
+          <p:cNvSpPr txBox="1"/>
+          <p:nvPr/>
+        </p:nvSpPr>
+        <p:spPr>
+          <a:xfrm>
+            <a:off x="5150000" y="2870320"/>
+            <a:ext cx="4211170" cy="330000"/>
+          </a:xfrm>
+          <a:prstGeom prst="rect">
+            <a:avLst/>
+          </a:prstGeom>
+          <a:noFill/>
+          <a:ln w="9525">
+            <a:noFill/>
+          </a:ln>
+        </p:spPr>
+        <p:txBody>
+          <a:bodyPr wrap="square" anchor="ctr" lIns="45720" tIns="18288" rIns="45720" bIns="18288">
+            <a:normAutofit/>
+          </a:bodyPr>
+          <a:lstStyle/>
+          <a:p>
+            <a:pPr algn="l">
+              <a:buNone/>
+            </a:pPr>
+            <a:r>
+              <a:rPr lang="ko-KR" altLang="en-US" sz="1250" b="1" dirty="0">
+                <a:solidFill>
+                  <a:srgbClr val="1F497D"/>
+                </a:solidFill>
+                <a:latin typeface="맑은 고딕"/>
+                <a:ea typeface="맑은 고딕"/>
+                <a:cs typeface="맑은 고딕"/>
+              </a:rPr>
+              <a:t xml:space="preserve">DVWA 14개 모듈 — 전부 탐지(14/14)</a:t>
+            </a:r>
+          </a:p>
+        </p:txBody>
+      </p:sp>
+      <p:sp>
+        <p:nvSpPr>
+          <p:cNvPr id="206" name="viz206"/>
+          <p:cNvSpPr txBox="1"/>
+          <p:nvPr/>
+        </p:nvSpPr>
+        <p:spPr>
+          <a:xfrm>
+            <a:off x="5150000" y="3230320"/>
+            <a:ext cx="2045585" cy="2250000"/>
+          </a:xfrm>
+          <a:prstGeom prst="rect">
+            <a:avLst/>
+          </a:prstGeom>
+          <a:noFill/>
+          <a:ln w="9525">
+            <a:noFill/>
+          </a:ln>
+        </p:spPr>
+        <p:txBody>
+          <a:bodyPr wrap="square" anchor="t" lIns="45720" tIns="18288" rIns="45720" bIns="18288">
+            <a:normAutofit/>
+          </a:bodyPr>
+          <a:lstStyle/>
+          <a:p>
+            <a:pPr algn="l">
+              <a:buNone/>
+              <a:spcAft>
+                <a:spcPts val="400"/>
+              </a:spcAft>
+            </a:pPr>
+            <a:r>
+              <a:rPr lang="ko-KR" altLang="en-US" sz="1200" b="1" dirty="0">
+                <a:solidFill>
+                  <a:srgbClr val="2E7D32"/>
+                </a:solidFill>
+                <a:latin typeface="맑은 고딕"/>
+                <a:ea typeface="맑은 고딕"/>
+                <a:cs typeface="맑은 고딕"/>
+              </a:rPr>
+              <a:t xml:space="preserve">✓ </a:t>
+            </a:r>
+            <a:r>
+              <a:rPr lang="ko-KR" altLang="en-US" sz="1150" b="0" dirty="0">
+                <a:solidFill>
+                  <a:srgbClr val="333333"/>
+                </a:solidFill>
+                <a:latin typeface="맑은 고딕"/>
+                <a:ea typeface="맑은 고딕"/>
+                <a:cs typeface="맑은 고딕"/>
+              </a:rPr>
+              <a:t xml:space="preserve">sqli</a:t>
+            </a:r>
+          </a:p>
+          <a:p>
+            <a:pPr algn="l">
+              <a:buNone/>
+              <a:spcAft>
+                <a:spcPts val="400"/>
+              </a:spcAft>
+            </a:pPr>
+            <a:r>
+              <a:rPr lang="ko-KR" altLang="en-US" sz="1200" b="1" dirty="0">
+                <a:solidFill>
+                  <a:srgbClr val="2E7D32"/>
+                </a:solidFill>
+                <a:latin typeface="맑은 고딕"/>
+                <a:ea typeface="맑은 고딕"/>
+                <a:cs typeface="맑은 고딕"/>
+              </a:rPr>
+              <a:t xml:space="preserve">✓ </a:t>
+            </a:r>
+            <a:r>
+              <a:rPr lang="ko-KR" altLang="en-US" sz="1150" b="0" dirty="0">
+                <a:solidFill>
+                  <a:srgbClr val="333333"/>
+                </a:solidFill>
+                <a:latin typeface="맑은 고딕"/>
+                <a:ea typeface="맑은 고딕"/>
+                <a:cs typeface="맑은 고딕"/>
+              </a:rPr>
+              <a:t xml:space="preserve">sqli_blind</a:t>
+            </a:r>
+          </a:p>
+          <a:p>
+            <a:pPr algn="l">
+              <a:buNone/>
+              <a:spcAft>
+                <a:spcPts val="400"/>
+              </a:spcAft>
+            </a:pPr>
+            <a:r>
+              <a:rPr lang="ko-KR" altLang="en-US" sz="1200" b="1" dirty="0">
+                <a:solidFill>
+                  <a:srgbClr val="2E7D32"/>
+                </a:solidFill>
+                <a:latin typeface="맑은 고딕"/>
+                <a:ea typeface="맑은 고딕"/>
+                <a:cs typeface="맑은 고딕"/>
+              </a:rPr>
+              <a:t xml:space="preserve">✓ </a:t>
+            </a:r>
+            <a:r>
+              <a:rPr lang="ko-KR" altLang="en-US" sz="1150" b="0" dirty="0">
+                <a:solidFill>
+                  <a:srgbClr val="333333"/>
+                </a:solidFill>
+                <a:latin typeface="맑은 고딕"/>
+                <a:ea typeface="맑은 고딕"/>
+                <a:cs typeface="맑은 고딕"/>
+              </a:rPr>
+              <a:t xml:space="preserve">exec</a:t>
+            </a:r>
+          </a:p>
+          <a:p>
+            <a:pPr algn="l">
+              <a:buNone/>
+              <a:spcAft>
+                <a:spcPts val="400"/>
+              </a:spcAft>
+            </a:pPr>
+            <a:r>
+              <a:rPr lang="ko-KR" altLang="en-US" sz="1200" b="1" dirty="0">
+                <a:solidFill>
+                  <a:srgbClr val="2E7D32"/>
+                </a:solidFill>
+                <a:latin typeface="맑은 고딕"/>
+                <a:ea typeface="맑은 고딕"/>
+                <a:cs typeface="맑은 고딕"/>
+              </a:rPr>
+              <a:t xml:space="preserve">✓ </a:t>
+            </a:r>
+            <a:r>
+              <a:rPr lang="ko-KR" altLang="en-US" sz="1150" b="0" dirty="0">
+                <a:solidFill>
+                  <a:srgbClr val="333333"/>
+                </a:solidFill>
+                <a:latin typeface="맑은 고딕"/>
+                <a:ea typeface="맑은 고딕"/>
+                <a:cs typeface="맑은 고딕"/>
+              </a:rPr>
+              <a:t xml:space="preserve">fi</a:t>
+            </a:r>
+          </a:p>
+          <a:p>
+            <a:pPr algn="l">
+              <a:buNone/>
+              <a:spcAft>
+                <a:spcPts val="400"/>
+              </a:spcAft>
+            </a:pPr>
+            <a:r>
+              <a:rPr lang="ko-KR" altLang="en-US" sz="1200" b="1" dirty="0">
+                <a:solidFill>
+                  <a:srgbClr val="2E7D32"/>
+                </a:solidFill>
+                <a:latin typeface="맑은 고딕"/>
+                <a:ea typeface="맑은 고딕"/>
+                <a:cs typeface="맑은 고딕"/>
+              </a:rPr>
+              <a:t xml:space="preserve">✓ </a:t>
+            </a:r>
+            <a:r>
+              <a:rPr lang="ko-KR" altLang="en-US" sz="1150" b="0" dirty="0">
+                <a:solidFill>
+                  <a:srgbClr val="333333"/>
+                </a:solidFill>
+                <a:latin typeface="맑은 고딕"/>
+                <a:ea typeface="맑은 고딕"/>
+                <a:cs typeface="맑은 고딕"/>
+              </a:rPr>
+              <a:t xml:space="preserve">upload</a:t>
+            </a:r>
+          </a:p>
+          <a:p>
+            <a:pPr algn="l">
+              <a:buNone/>
+              <a:spcAft>
+                <a:spcPts val="400"/>
+              </a:spcAft>
+            </a:pPr>
+            <a:r>
+              <a:rPr lang="ko-KR" altLang="en-US" sz="1200" b="1" dirty="0">
+                <a:solidFill>
+                  <a:srgbClr val="2E7D32"/>
+                </a:solidFill>
+                <a:latin typeface="맑은 고딕"/>
+                <a:ea typeface="맑은 고딕"/>
+                <a:cs typeface="맑은 고딕"/>
+              </a:rPr>
+              <a:t xml:space="preserve">✓ </a:t>
+            </a:r>
+            <a:r>
+              <a:rPr lang="ko-KR" altLang="en-US" sz="1150" b="0" dirty="0">
+                <a:solidFill>
+                  <a:srgbClr val="333333"/>
+                </a:solidFill>
+                <a:latin typeface="맑은 고딕"/>
+                <a:ea typeface="맑은 고딕"/>
+                <a:cs typeface="맑은 고딕"/>
+              </a:rPr>
+              <a:t xml:space="preserve">xss_r</a:t>
+            </a:r>
+          </a:p>
+          <a:p>
+            <a:pPr algn="l">
+              <a:buNone/>
+              <a:spcAft>
+                <a:spcPts val="400"/>
+              </a:spcAft>
+            </a:pPr>
+            <a:r>
+              <a:rPr lang="ko-KR" altLang="en-US" sz="1200" b="1" dirty="0">
+                <a:solidFill>
+                  <a:srgbClr val="2E7D32"/>
+                </a:solidFill>
+                <a:latin typeface="맑은 고딕"/>
+                <a:ea typeface="맑은 고딕"/>
+                <a:cs typeface="맑은 고딕"/>
+              </a:rPr>
+              <a:t xml:space="preserve">✓ </a:t>
+            </a:r>
+            <a:r>
+              <a:rPr lang="ko-KR" altLang="en-US" sz="1150" b="0" dirty="0">
+                <a:solidFill>
+                  <a:srgbClr val="333333"/>
+                </a:solidFill>
+                <a:latin typeface="맑은 고딕"/>
+                <a:ea typeface="맑은 고딕"/>
+                <a:cs typeface="맑은 고딕"/>
+              </a:rPr>
+              <a:t xml:space="preserve">xss_s</a:t>
+            </a:r>
+          </a:p>
+        </p:txBody>
+      </p:sp>
+      <p:sp>
+        <p:nvSpPr>
+          <p:cNvPr id="207" name="viz207"/>
+          <p:cNvSpPr txBox="1"/>
+          <p:nvPr/>
+        </p:nvSpPr>
+        <p:spPr>
+          <a:xfrm>
+            <a:off x="7315585" y="3230320"/>
+            <a:ext cx="2045585" cy="2250000"/>
+          </a:xfrm>
+          <a:prstGeom prst="rect">
+            <a:avLst/>
+          </a:prstGeom>
+          <a:noFill/>
+          <a:ln w="9525">
+            <a:noFill/>
+          </a:ln>
+        </p:spPr>
+        <p:txBody>
+          <a:bodyPr wrap="square" anchor="t" lIns="45720" tIns="18288" rIns="45720" bIns="18288">
+            <a:normAutofit/>
+          </a:bodyPr>
+          <a:lstStyle/>
+          <a:p>
+            <a:pPr algn="l">
+              <a:buNone/>
+              <a:spcAft>
+                <a:spcPts val="400"/>
+              </a:spcAft>
+            </a:pPr>
+            <a:r>
+              <a:rPr lang="ko-KR" altLang="en-US" sz="1200" b="1" dirty="0">
+                <a:solidFill>
+                  <a:srgbClr val="2E7D32"/>
+                </a:solidFill>
+                <a:latin typeface="맑은 고딕"/>
+                <a:ea typeface="맑은 고딕"/>
+                <a:cs typeface="맑은 고딕"/>
+              </a:rPr>
+              <a:t xml:space="preserve">✓ </a:t>
+            </a:r>
+            <a:r>
+              <a:rPr lang="ko-KR" altLang="en-US" sz="1150" b="0" dirty="0">
+                <a:solidFill>
+                  <a:srgbClr val="333333"/>
+                </a:solidFill>
+                <a:latin typeface="맑은 고딕"/>
+                <a:ea typeface="맑은 고딕"/>
+                <a:cs typeface="맑은 고딕"/>
+              </a:rPr>
+              <a:t xml:space="preserve">xss_d</a:t>
+            </a:r>
+          </a:p>
+          <a:p>
+            <a:pPr algn="l">
+              <a:buNone/>
+              <a:spcAft>
+                <a:spcPts val="400"/>
+              </a:spcAft>
+            </a:pPr>
+            <a:r>
+              <a:rPr lang="ko-KR" altLang="en-US" sz="1200" b="1" dirty="0">
+                <a:solidFill>
+                  <a:srgbClr val="2E7D32"/>
+                </a:solidFill>
+                <a:latin typeface="맑은 고딕"/>
+                <a:ea typeface="맑은 고딕"/>
+                <a:cs typeface="맑은 고딕"/>
+              </a:rPr>
+              <a:t xml:space="preserve">✓ </a:t>
+            </a:r>
+            <a:r>
+              <a:rPr lang="ko-KR" altLang="en-US" sz="1150" b="0" dirty="0">
+                <a:solidFill>
+                  <a:srgbClr val="333333"/>
+                </a:solidFill>
+                <a:latin typeface="맑은 고딕"/>
+                <a:ea typeface="맑은 고딕"/>
+                <a:cs typeface="맑은 고딕"/>
+              </a:rPr>
+              <a:t xml:space="preserve">csrf</a:t>
+            </a:r>
+          </a:p>
+          <a:p>
+            <a:pPr algn="l">
+              <a:buNone/>
+              <a:spcAft>
+                <a:spcPts val="400"/>
+              </a:spcAft>
+            </a:pPr>
+            <a:r>
+              <a:rPr lang="ko-KR" altLang="en-US" sz="1200" b="1" dirty="0">
+                <a:solidFill>
+                  <a:srgbClr val="2E7D32"/>
+                </a:solidFill>
+                <a:latin typeface="맑은 고딕"/>
+                <a:ea typeface="맑은 고딕"/>
+                <a:cs typeface="맑은 고딕"/>
+              </a:rPr>
+              <a:t xml:space="preserve">✓ </a:t>
+            </a:r>
+            <a:r>
+              <a:rPr lang="ko-KR" altLang="en-US" sz="1150" b="0" dirty="0">
+                <a:solidFill>
+                  <a:srgbClr val="333333"/>
+                </a:solidFill>
+                <a:latin typeface="맑은 고딕"/>
+                <a:ea typeface="맑은 고딕"/>
+                <a:cs typeface="맑은 고딕"/>
+              </a:rPr>
+              <a:t xml:space="preserve">brute</a:t>
+            </a:r>
+          </a:p>
+          <a:p>
+            <a:pPr algn="l">
+              <a:buNone/>
+              <a:spcAft>
+                <a:spcPts val="400"/>
+              </a:spcAft>
+            </a:pPr>
+            <a:r>
+              <a:rPr lang="ko-KR" altLang="en-US" sz="1200" b="1" dirty="0">
+                <a:solidFill>
+                  <a:srgbClr val="2E7D32"/>
+                </a:solidFill>
+                <a:latin typeface="맑은 고딕"/>
+                <a:ea typeface="맑은 고딕"/>
+                <a:cs typeface="맑은 고딕"/>
+              </a:rPr>
+              <a:t xml:space="preserve">✓ </a:t>
+            </a:r>
+            <a:r>
+              <a:rPr lang="ko-KR" altLang="en-US" sz="1150" b="0" dirty="0">
+                <a:solidFill>
+                  <a:srgbClr val="333333"/>
+                </a:solidFill>
+                <a:latin typeface="맑은 고딕"/>
+                <a:ea typeface="맑은 고딕"/>
+                <a:cs typeface="맑은 고딕"/>
+              </a:rPr>
+              <a:t xml:space="preserve">weak_id</a:t>
+            </a:r>
+          </a:p>
+          <a:p>
+            <a:pPr algn="l">
+              <a:buNone/>
+              <a:spcAft>
+                <a:spcPts val="400"/>
+              </a:spcAft>
+            </a:pPr>
+            <a:r>
+              <a:rPr lang="ko-KR" altLang="en-US" sz="1200" b="1" dirty="0">
+                <a:solidFill>
+                  <a:srgbClr val="2E7D32"/>
+                </a:solidFill>
+                <a:latin typeface="맑은 고딕"/>
+                <a:ea typeface="맑은 고딕"/>
+                <a:cs typeface="맑은 고딕"/>
+              </a:rPr>
+              <a:t xml:space="preserve">✓ </a:t>
+            </a:r>
+            <a:r>
+              <a:rPr lang="ko-KR" altLang="en-US" sz="1150" b="0" dirty="0">
+                <a:solidFill>
+                  <a:srgbClr val="333333"/>
+                </a:solidFill>
+                <a:latin typeface="맑은 고딕"/>
+                <a:ea typeface="맑은 고딕"/>
+                <a:cs typeface="맑은 고딕"/>
+              </a:rPr>
+              <a:t xml:space="preserve">csp</a:t>
+            </a:r>
+          </a:p>
+          <a:p>
+            <a:pPr algn="l">
+              <a:buNone/>
+              <a:spcAft>
+                <a:spcPts val="400"/>
+              </a:spcAft>
+            </a:pPr>
+            <a:r>
+              <a:rPr lang="ko-KR" altLang="en-US" sz="1200" b="1" dirty="0">
+                <a:solidFill>
+                  <a:srgbClr val="2E7D32"/>
+                </a:solidFill>
+                <a:latin typeface="맑은 고딕"/>
+                <a:ea typeface="맑은 고딕"/>
+                <a:cs typeface="맑은 고딕"/>
+              </a:rPr>
+              <a:t xml:space="preserve">✓ </a:t>
+            </a:r>
+            <a:r>
+              <a:rPr lang="ko-KR" altLang="en-US" sz="1150" b="0" dirty="0">
+                <a:solidFill>
+                  <a:srgbClr val="333333"/>
+                </a:solidFill>
+                <a:latin typeface="맑은 고딕"/>
+                <a:ea typeface="맑은 고딕"/>
+                <a:cs typeface="맑은 고딕"/>
+              </a:rPr>
+              <a:t xml:space="preserve">javascript</a:t>
+            </a:r>
+          </a:p>
+          <a:p>
+            <a:pPr algn="l">
+              <a:buNone/>
+              <a:spcAft>
+                <a:spcPts val="400"/>
+              </a:spcAft>
+            </a:pPr>
+            <a:r>
+              <a:rPr lang="ko-KR" altLang="en-US" sz="1200" b="1" dirty="0">
+                <a:solidFill>
+                  <a:srgbClr val="2E7D32"/>
+                </a:solidFill>
+                <a:latin typeface="맑은 고딕"/>
+                <a:ea typeface="맑은 고딕"/>
+                <a:cs typeface="맑은 고딕"/>
+              </a:rPr>
+              <a:t xml:space="preserve">✓ </a:t>
+            </a:r>
+            <a:r>
+              <a:rPr lang="ko-KR" altLang="en-US" sz="1150" b="0" dirty="0">
+                <a:solidFill>
+                  <a:srgbClr val="333333"/>
+                </a:solidFill>
+                <a:latin typeface="맑은 고딕"/>
+                <a:ea typeface="맑은 고딕"/>
+                <a:cs typeface="맑은 고딕"/>
+              </a:rPr>
+              <a:t xml:space="preserve">captcha</a:t>
+            </a:r>
+          </a:p>
+        </p:txBody>
+      </p:sp>
+      <p:sp>
+        <p:nvSpPr>
+          <p:cNvPr id="208" name="viz208"/>
+          <p:cNvSpPr txBox="1"/>
+          <p:nvPr/>
+        </p:nvSpPr>
+        <p:spPr>
+          <a:xfrm>
+            <a:off x="5150000" y="5550320"/>
+            <a:ext cx="4211170" cy="470000"/>
+          </a:xfrm>
+          <a:prstGeom prst="roundRect">
+            <a:avLst>
+              <a:gd name="adj" fmla="val 6000"/>
+            </a:avLst>
+          </a:prstGeom>
+          <a:solidFill>
+            <a:srgbClr val="FBEEE9"/>
+          </a:solidFill>
+          <a:ln w="9525">
+            <a:solidFill>
+              <a:srgbClr val="E7C3BB"/>
+            </a:solidFill>
+          </a:ln>
+        </p:spPr>
+        <p:txBody>
+          <a:bodyPr wrap="square" anchor="ctr" lIns="45720" tIns="18288" rIns="45720" bIns="18288">
+            <a:normAutofit/>
+          </a:bodyPr>
+          <a:lstStyle/>
+          <a:p>
+            <a:pPr algn="l">
+              <a:buNone/>
+            </a:pPr>
+            <a:r>
+              <a:rPr lang="ko-KR" altLang="en-US" sz="1150" b="1" dirty="0">
+                <a:solidFill>
+                  <a:srgbClr val="C0504D"/>
+                </a:solidFill>
+                <a:latin typeface="맑은 고딕"/>
+                <a:ea typeface="맑은 고딕"/>
+                <a:cs typeface="맑은 고딕"/>
+              </a:rPr>
+              <a:t xml:space="preserve">＋ 보너스  </a:t>
+            </a:r>
+            <a:r>
+              <a:rPr lang="ko-KR" altLang="en-US" sz="1100" b="0" dirty="0">
+                <a:solidFill>
+                  <a:srgbClr val="333333"/>
+                </a:solidFill>
+                <a:latin typeface="맑은 고딕"/>
+                <a:ea typeface="맑은 고딕"/>
+                <a:cs typeface="맑은 고딕"/>
+              </a:rPr>
+              <a:t xml:space="preserve">디렉터리 리스팅(서버 설정 결함) — 정답지 밖 1건</a:t>
             </a:r>
           </a:p>
         </p:txBody>

</xml_diff>